<commit_message>
finish preparing the recording video
</commit_message>
<xml_diff>
--- a/docs/Indivisa-pitch.pptx
+++ b/docs/Indivisa-pitch.pptx
@@ -692,7 +692,7 @@
           <a:p>
             <a:r>
               <a:rPr lang="en-US" dirty="0"/>
-              <a:t>Real paying agents have four-eyes controls. Below the threshold this is not our code being careful — it is the ledger refusing.</a:t>
+              <a:t>Real paying agents have four-eyes controls. Below the threshold this is not our code being careful. It is the ledger refusing.</a:t>
             </a:r>
             <a:endParaRPr lang="en-US" dirty="0"/>
           </a:p>
@@ -1132,7 +1132,7 @@
           <a:p>
             <a:r>
               <a:rPr lang="en-US" dirty="0"/>
-              <a:t>These are not our numbers. They are from Canton Network's own post-trade research. Error rates between three and ten per cent are described there as routine — levels called unacceptable elsewhere in capital markets.</a:t>
+              <a:t>These are not our numbers. They are from Canton Network's own post-trade research. Error rates between three and ten per cent are described there as routine: levels called unacceptable elsewhere in capital markets.</a:t>
             </a:r>
             <a:endParaRPr lang="en-US" dirty="0"/>
           </a:p>
@@ -3214,7 +3214,7 @@
                 <a:ea typeface="Calibri" pitchFamily="34" charset="-122"/>
                 <a:cs typeface="Calibri" pitchFamily="34" charset="-120"/>
               </a:rPr>
-              <a:t> — and it is final.</a:t>
+              <a:t>, and it is final.</a:t>
             </a:r>
             <a:endParaRPr lang="en-US" sz="1700" dirty="0"/>
           </a:p>
@@ -3470,7 +3470,7 @@
                 <a:ea typeface="Calibri" pitchFamily="34" charset="-122"/>
                 <a:cs typeface="Calibri" pitchFamily="34" charset="-120"/>
               </a:rPr>
-              <a:t>A run can name an approver: a decentralised party, through BitSafe's Decentralization Manager. One optional field — the product is unchanged without it.</a:t>
+              <a:t>A run can name an approver: a decentralised party, through BitSafe's Decentralization Manager. One optional field. The product is unchanged without it.</a:t>
             </a:r>
             <a:endParaRPr lang="en-US" sz="1500" dirty="0"/>
           </a:p>
@@ -4166,7 +4166,7 @@
                 <a:ea typeface="Calibri" pitchFamily="34" charset="-122"/>
                 <a:cs typeface="Calibri" pitchFamily="34" charset="-120"/>
               </a:rPr>
-              <a:t>The cash is TestTokenV2, the standard's own reference asset, not Canton Coin — chosen because it is signed by owner and admin, so it forces the same receiver-authorisation case. Holders and positions are generated. Three approver nodes on one machine are not three independent operators.</a:t>
+              <a:t>The cash is TestTokenV2, the standard's own reference asset, not Canton Coin, chosen because it is signed by owner and admin, so it forces the same receiver-authorisation case. Holders and positions are generated. Three approver nodes on one machine are not three independent operators.</a:t>
             </a:r>
             <a:endParaRPr lang="en-US" sz="1100" dirty="0"/>
           </a:p>
@@ -4613,24 +4613,24 @@
         </p:nvSpPr>
         <p:spPr>
           <a:xfrm>
-            <a:off x="800100" y="3520440"/>
-            <a:ext cx="274320" cy="274320"/>
-          </a:xfrm>
-          <a:prstGeom prst="rect">
-            <a:avLst/>
-          </a:prstGeom>
-          <a:noFill/>
-          <a:ln/>
-        </p:spPr>
-        <p:txBody>
-          <a:bodyPr wrap="square" lIns="0" tIns="0" rIns="0" bIns="0" rtlCol="0" anchor="ctr"/>
-          <a:lstStyle/>
-          <a:p>
-            <a:pPr indent="0" marL="0">
-              <a:buNone/>
-            </a:pPr>
-            <a:r>
-              <a:rPr lang="en-US" sz="1200" dirty="0">
+            <a:off x="836676" y="3493008"/>
+            <a:ext cx="274320" cy="292608"/>
+          </a:xfrm>
+          <a:prstGeom prst="rect">
+            <a:avLst/>
+          </a:prstGeom>
+          <a:noFill/>
+          <a:ln/>
+        </p:spPr>
+        <p:txBody>
+          <a:bodyPr wrap="square" lIns="0" tIns="0" rIns="0" bIns="0" rtlCol="0" anchor="ctr"/>
+          <a:lstStyle/>
+          <a:p>
+            <a:pPr indent="0" marL="0">
+              <a:buNone/>
+            </a:pPr>
+            <a:r>
+              <a:rPr lang="en-US" sz="1900" b="1" dirty="0">
                 <a:solidFill>
                   <a:srgbClr val="58BE8A"/>
                 </a:solidFill>
@@ -4638,9 +4638,9 @@
                 <a:ea typeface="Calibri" pitchFamily="34" charset="-122"/>
                 <a:cs typeface="Calibri" pitchFamily="34" charset="-120"/>
               </a:rPr>
-              <a:t>—</a:t>
-            </a:r>
-            <a:endParaRPr lang="en-US" sz="1200" dirty="0"/>
+              <a:t>·</a:t>
+            </a:r>
+            <a:endParaRPr lang="en-US" sz="1900" dirty="0"/>
           </a:p>
         </p:txBody>
       </p:sp>
@@ -4697,7 +4697,7 @@
                 <a:ea typeface="Calibri" pitchFamily="34" charset="-122"/>
                 <a:cs typeface="Calibri" pitchFamily="34" charset="-120"/>
               </a:rPr>
-              <a:t> — holders sign through a real client, not a script.</a:t>
+              <a:t>: holders sign through a real client, not a script.</a:t>
             </a:r>
             <a:endParaRPr lang="en-US" sz="1200" dirty="0"/>
           </a:p>
@@ -4711,24 +4711,24 @@
         </p:nvSpPr>
         <p:spPr>
           <a:xfrm>
-            <a:off x="800100" y="4032504"/>
-            <a:ext cx="274320" cy="274320"/>
-          </a:xfrm>
-          <a:prstGeom prst="rect">
-            <a:avLst/>
-          </a:prstGeom>
-          <a:noFill/>
-          <a:ln/>
-        </p:spPr>
-        <p:txBody>
-          <a:bodyPr wrap="square" lIns="0" tIns="0" rIns="0" bIns="0" rtlCol="0" anchor="ctr"/>
-          <a:lstStyle/>
-          <a:p>
-            <a:pPr indent="0" marL="0">
-              <a:buNone/>
-            </a:pPr>
-            <a:r>
-              <a:rPr lang="en-US" sz="1200" dirty="0">
+            <a:off x="836676" y="4005072"/>
+            <a:ext cx="274320" cy="292608"/>
+          </a:xfrm>
+          <a:prstGeom prst="rect">
+            <a:avLst/>
+          </a:prstGeom>
+          <a:noFill/>
+          <a:ln/>
+        </p:spPr>
+        <p:txBody>
+          <a:bodyPr wrap="square" lIns="0" tIns="0" rIns="0" bIns="0" rtlCol="0" anchor="ctr"/>
+          <a:lstStyle/>
+          <a:p>
+            <a:pPr indent="0" marL="0">
+              <a:buNone/>
+            </a:pPr>
+            <a:r>
+              <a:rPr lang="en-US" sz="1900" b="1" dirty="0">
                 <a:solidFill>
                   <a:srgbClr val="58BE8A"/>
                 </a:solidFill>
@@ -4736,9 +4736,9 @@
                 <a:ea typeface="Calibri" pitchFamily="34" charset="-122"/>
                 <a:cs typeface="Calibri" pitchFamily="34" charset="-120"/>
               </a:rPr>
-              <a:t>—</a:t>
-            </a:r>
-            <a:endParaRPr lang="en-US" sz="1200" dirty="0"/>
+              <a:t>·</a:t>
+            </a:r>
+            <a:endParaRPr lang="en-US" sz="1900" dirty="0"/>
           </a:p>
         </p:txBody>
       </p:sp>
@@ -4795,7 +4795,7 @@
                 <a:ea typeface="Calibri" pitchFamily="34" charset="-122"/>
                 <a:cs typeface="Calibri" pitchFamily="34" charset="-120"/>
               </a:rPr>
-              <a:t> — today a person presses the button; in production a daemon watches payment dates.</a:t>
+              <a:t>: today a person presses the button; in production a daemon watches payment dates.</a:t>
             </a:r>
             <a:endParaRPr lang="en-US" sz="1200" dirty="0"/>
           </a:p>
@@ -4809,24 +4809,24 @@
         </p:nvSpPr>
         <p:spPr>
           <a:xfrm>
-            <a:off x="800100" y="4544568"/>
-            <a:ext cx="274320" cy="274320"/>
-          </a:xfrm>
-          <a:prstGeom prst="rect">
-            <a:avLst/>
-          </a:prstGeom>
-          <a:noFill/>
-          <a:ln/>
-        </p:spPr>
-        <p:txBody>
-          <a:bodyPr wrap="square" lIns="0" tIns="0" rIns="0" bIns="0" rtlCol="0" anchor="ctr"/>
-          <a:lstStyle/>
-          <a:p>
-            <a:pPr indent="0" marL="0">
-              <a:buNone/>
-            </a:pPr>
-            <a:r>
-              <a:rPr lang="en-US" sz="1200" dirty="0">
+            <a:off x="836676" y="4517136"/>
+            <a:ext cx="274320" cy="292608"/>
+          </a:xfrm>
+          <a:prstGeom prst="rect">
+            <a:avLst/>
+          </a:prstGeom>
+          <a:noFill/>
+          <a:ln/>
+        </p:spPr>
+        <p:txBody>
+          <a:bodyPr wrap="square" lIns="0" tIns="0" rIns="0" bIns="0" rtlCol="0" anchor="ctr"/>
+          <a:lstStyle/>
+          <a:p>
+            <a:pPr indent="0" marL="0">
+              <a:buNone/>
+            </a:pPr>
+            <a:r>
+              <a:rPr lang="en-US" sz="1900" b="1" dirty="0">
                 <a:solidFill>
                   <a:srgbClr val="58BE8A"/>
                 </a:solidFill>
@@ -4834,9 +4834,9 @@
                 <a:ea typeface="Calibri" pitchFamily="34" charset="-122"/>
                 <a:cs typeface="Calibri" pitchFamily="34" charset="-120"/>
               </a:rPr>
-              <a:t>—</a:t>
-            </a:r>
-            <a:endParaRPr lang="en-US" sz="1200" dirty="0"/>
+              <a:t>·</a:t>
+            </a:r>
+            <a:endParaRPr lang="en-US" sz="1900" dirty="0"/>
           </a:p>
         </p:txBody>
       </p:sp>
@@ -4893,7 +4893,7 @@
                 <a:ea typeface="Calibri" pitchFamily="34" charset="-122"/>
                 <a:cs typeface="Calibri" pitchFamily="34" charset="-120"/>
               </a:rPr>
-              <a:t> — a production run settles Canton Coin or a registry's own token. The model never names the asset, so this is a field and one registry adapter, not a rewrite.</a:t>
+              <a:t>: a production run settles Canton Coin or a registry's own token. The model never names the asset, so this is a field and one registry adapter, not a rewrite.</a:t>
             </a:r>
             <a:endParaRPr lang="en-US" sz="1200" dirty="0"/>
           </a:p>
@@ -4907,24 +4907,24 @@
         </p:nvSpPr>
         <p:spPr>
           <a:xfrm>
-            <a:off x="800100" y="5257800"/>
-            <a:ext cx="274320" cy="274320"/>
-          </a:xfrm>
-          <a:prstGeom prst="rect">
-            <a:avLst/>
-          </a:prstGeom>
-          <a:noFill/>
-          <a:ln/>
-        </p:spPr>
-        <p:txBody>
-          <a:bodyPr wrap="square" lIns="0" tIns="0" rIns="0" bIns="0" rtlCol="0" anchor="ctr"/>
-          <a:lstStyle/>
-          <a:p>
-            <a:pPr indent="0" marL="0">
-              <a:buNone/>
-            </a:pPr>
-            <a:r>
-              <a:rPr lang="en-US" sz="1200" dirty="0">
+            <a:off x="836676" y="5230368"/>
+            <a:ext cx="274320" cy="292608"/>
+          </a:xfrm>
+          <a:prstGeom prst="rect">
+            <a:avLst/>
+          </a:prstGeom>
+          <a:noFill/>
+          <a:ln/>
+        </p:spPr>
+        <p:txBody>
+          <a:bodyPr wrap="square" lIns="0" tIns="0" rIns="0" bIns="0" rtlCol="0" anchor="ctr"/>
+          <a:lstStyle/>
+          <a:p>
+            <a:pPr indent="0" marL="0">
+              <a:buNone/>
+            </a:pPr>
+            <a:r>
+              <a:rPr lang="en-US" sz="1900" b="1" dirty="0">
                 <a:solidFill>
                   <a:srgbClr val="58BE8A"/>
                 </a:solidFill>
@@ -4932,9 +4932,9 @@
                 <a:ea typeface="Calibri" pitchFamily="34" charset="-122"/>
                 <a:cs typeface="Calibri" pitchFamily="34" charset="-120"/>
               </a:rPr>
-              <a:t>—</a:t>
-            </a:r>
-            <a:endParaRPr lang="en-US" sz="1200" dirty="0"/>
+              <a:t>·</a:t>
+            </a:r>
+            <a:endParaRPr lang="en-US" sz="1900" dirty="0"/>
           </a:p>
         </p:txBody>
       </p:sp>
@@ -4991,7 +4991,7 @@
                 <a:ea typeface="Calibri" pitchFamily="34" charset="-122"/>
                 <a:cs typeface="Calibri" pitchFamily="34" charset="-120"/>
               </a:rPr>
-              <a:t> — the DevNet run proves the path; MainNet is a deployment decision, not a code change. We run validator infrastructure, and it is the first thing after submission.</a:t>
+              <a:t>: the DevNet run proves the path; MainNet is a deployment decision, not a code change. We run validator infrastructure, and it is the first thing after submission.</a:t>
             </a:r>
             <a:endParaRPr lang="en-US" sz="1200" dirty="0"/>
           </a:p>
@@ -5180,24 +5180,24 @@
         </p:nvSpPr>
         <p:spPr>
           <a:xfrm>
-            <a:off x="800100" y="2651760"/>
-            <a:ext cx="274320" cy="274320"/>
-          </a:xfrm>
-          <a:prstGeom prst="rect">
-            <a:avLst/>
-          </a:prstGeom>
-          <a:noFill/>
-          <a:ln/>
-        </p:spPr>
-        <p:txBody>
-          <a:bodyPr wrap="square" lIns="0" tIns="0" rIns="0" bIns="0" rtlCol="0" anchor="ctr"/>
-          <a:lstStyle/>
-          <a:p>
-            <a:pPr indent="0" marL="0">
-              <a:buNone/>
-            </a:pPr>
-            <a:r>
-              <a:rPr lang="en-US" sz="1300" dirty="0">
+            <a:off x="836676" y="2624328"/>
+            <a:ext cx="274320" cy="292608"/>
+          </a:xfrm>
+          <a:prstGeom prst="rect">
+            <a:avLst/>
+          </a:prstGeom>
+          <a:noFill/>
+          <a:ln/>
+        </p:spPr>
+        <p:txBody>
+          <a:bodyPr wrap="square" lIns="0" tIns="0" rIns="0" bIns="0" rtlCol="0" anchor="ctr"/>
+          <a:lstStyle/>
+          <a:p>
+            <a:pPr indent="0" marL="0">
+              <a:buNone/>
+            </a:pPr>
+            <a:r>
+              <a:rPr lang="en-US" sz="2000" b="1" dirty="0">
                 <a:solidFill>
                   <a:srgbClr val="58BE8A"/>
                 </a:solidFill>
@@ -5205,9 +5205,9 @@
                 <a:ea typeface="Calibri" pitchFamily="34" charset="-122"/>
                 <a:cs typeface="Calibri" pitchFamily="34" charset="-120"/>
               </a:rPr>
-              <a:t>—</a:t>
-            </a:r>
-            <a:endParaRPr lang="en-US" sz="1300" dirty="0"/>
+              <a:t>·</a:t>
+            </a:r>
+            <a:endParaRPr lang="en-US" sz="2000" dirty="0"/>
           </a:p>
         </p:txBody>
       </p:sp>
@@ -5264,7 +5264,7 @@
                 <a:ea typeface="Calibri" pitchFamily="34" charset="-122"/>
                 <a:cs typeface="Calibri" pitchFamily="34" charset="-120"/>
               </a:rPr>
-              <a:t> — 328 registered transfer agents in the US alone. Small, named, and each running thousands of events a year.</a:t>
+              <a:t>: independent debt paying agents, corporate trustees, and the issuer-services arms of custodian banks. Small, named, and each running thousands of events a year.</a:t>
             </a:r>
             <a:endParaRPr lang="en-US" sz="1300" dirty="0"/>
           </a:p>
@@ -5278,24 +5278,24 @@
         </p:nvSpPr>
         <p:spPr>
           <a:xfrm>
-            <a:off x="800100" y="3364992"/>
-            <a:ext cx="274320" cy="274320"/>
-          </a:xfrm>
-          <a:prstGeom prst="rect">
-            <a:avLst/>
-          </a:prstGeom>
-          <a:noFill/>
-          <a:ln/>
-        </p:spPr>
-        <p:txBody>
-          <a:bodyPr wrap="square" lIns="0" tIns="0" rIns="0" bIns="0" rtlCol="0" anchor="ctr"/>
-          <a:lstStyle/>
-          <a:p>
-            <a:pPr indent="0" marL="0">
-              <a:buNone/>
-            </a:pPr>
-            <a:r>
-              <a:rPr lang="en-US" sz="1300" dirty="0">
+            <a:off x="836676" y="3337560"/>
+            <a:ext cx="274320" cy="292608"/>
+          </a:xfrm>
+          <a:prstGeom prst="rect">
+            <a:avLst/>
+          </a:prstGeom>
+          <a:noFill/>
+          <a:ln/>
+        </p:spPr>
+        <p:txBody>
+          <a:bodyPr wrap="square" lIns="0" tIns="0" rIns="0" bIns="0" rtlCol="0" anchor="ctr"/>
+          <a:lstStyle/>
+          <a:p>
+            <a:pPr indent="0" marL="0">
+              <a:buNone/>
+            </a:pPr>
+            <a:r>
+              <a:rPr lang="en-US" sz="2000" b="1" dirty="0">
                 <a:solidFill>
                   <a:srgbClr val="58BE8A"/>
                 </a:solidFill>
@@ -5303,9 +5303,9 @@
                 <a:ea typeface="Calibri" pitchFamily="34" charset="-122"/>
                 <a:cs typeface="Calibri" pitchFamily="34" charset="-120"/>
               </a:rPr>
-              <a:t>—</a:t>
-            </a:r>
-            <a:endParaRPr lang="en-US" sz="1300" dirty="0"/>
+              <a:t>·</a:t>
+            </a:r>
+            <a:endParaRPr lang="en-US" sz="2000" dirty="0"/>
           </a:p>
         </p:txBody>
       </p:sp>
@@ -5362,7 +5362,7 @@
                 <a:ea typeface="Calibri" pitchFamily="34" charset="-122"/>
                 <a:cs typeface="Calibri" pitchFamily="34" charset="-120"/>
               </a:rPr>
-              <a:t> — the same run, a different event type.</a:t>
+              <a:t>: the same run, a different event type.</a:t>
             </a:r>
             <a:endParaRPr lang="en-US" sz="1300" dirty="0"/>
           </a:p>
@@ -5376,24 +5376,24 @@
         </p:nvSpPr>
         <p:spPr>
           <a:xfrm>
-            <a:off x="800100" y="3877056"/>
-            <a:ext cx="274320" cy="274320"/>
-          </a:xfrm>
-          <a:prstGeom prst="rect">
-            <a:avLst/>
-          </a:prstGeom>
-          <a:noFill/>
-          <a:ln/>
-        </p:spPr>
-        <p:txBody>
-          <a:bodyPr wrap="square" lIns="0" tIns="0" rIns="0" bIns="0" rtlCol="0" anchor="ctr"/>
-          <a:lstStyle/>
-          <a:p>
-            <a:pPr indent="0" marL="0">
-              <a:buNone/>
-            </a:pPr>
-            <a:r>
-              <a:rPr lang="en-US" sz="1300" dirty="0">
+            <a:off x="836676" y="3849624"/>
+            <a:ext cx="274320" cy="292608"/>
+          </a:xfrm>
+          <a:prstGeom prst="rect">
+            <a:avLst/>
+          </a:prstGeom>
+          <a:noFill/>
+          <a:ln/>
+        </p:spPr>
+        <p:txBody>
+          <a:bodyPr wrap="square" lIns="0" tIns="0" rIns="0" bIns="0" rtlCol="0" anchor="ctr"/>
+          <a:lstStyle/>
+          <a:p>
+            <a:pPr indent="0" marL="0">
+              <a:buNone/>
+            </a:pPr>
+            <a:r>
+              <a:rPr lang="en-US" sz="2000" b="1" dirty="0">
                 <a:solidFill>
                   <a:srgbClr val="58BE8A"/>
                 </a:solidFill>
@@ -5401,9 +5401,9 @@
                 <a:ea typeface="Calibri" pitchFamily="34" charset="-122"/>
                 <a:cs typeface="Calibri" pitchFamily="34" charset="-120"/>
               </a:rPr>
-              <a:t>—</a:t>
-            </a:r>
-            <a:endParaRPr lang="en-US" sz="1300" dirty="0"/>
+              <a:t>·</a:t>
+            </a:r>
+            <a:endParaRPr lang="en-US" sz="2000" dirty="0"/>
           </a:p>
         </p:txBody>
       </p:sp>
@@ -5460,7 +5460,7 @@
                 <a:ea typeface="Calibri" pitchFamily="34" charset="-122"/>
                 <a:cs typeface="Calibri" pitchFamily="34" charset="-120"/>
               </a:rPr>
-              <a:t> — the bond is not tokenized; only the cash is a Token Standard V2 asset.</a:t>
+              <a:t>: the bond is not tokenized; only the cash is a Token Standard V2 asset.</a:t>
             </a:r>
             <a:endParaRPr lang="en-US" sz="1300" dirty="0"/>
           </a:p>
@@ -5474,24 +5474,24 @@
         </p:nvSpPr>
         <p:spPr>
           <a:xfrm>
-            <a:off x="800100" y="4389120"/>
-            <a:ext cx="274320" cy="274320"/>
-          </a:xfrm>
-          <a:prstGeom prst="rect">
-            <a:avLst/>
-          </a:prstGeom>
-          <a:noFill/>
-          <a:ln/>
-        </p:spPr>
-        <p:txBody>
-          <a:bodyPr wrap="square" lIns="0" tIns="0" rIns="0" bIns="0" rtlCol="0" anchor="ctr"/>
-          <a:lstStyle/>
-          <a:p>
-            <a:pPr indent="0" marL="0">
-              <a:buNone/>
-            </a:pPr>
-            <a:r>
-              <a:rPr lang="en-US" sz="1300" dirty="0">
+            <a:off x="836676" y="4361688"/>
+            <a:ext cx="274320" cy="292608"/>
+          </a:xfrm>
+          <a:prstGeom prst="rect">
+            <a:avLst/>
+          </a:prstGeom>
+          <a:noFill/>
+          <a:ln/>
+        </p:spPr>
+        <p:txBody>
+          <a:bodyPr wrap="square" lIns="0" tIns="0" rIns="0" bIns="0" rtlCol="0" anchor="ctr"/>
+          <a:lstStyle/>
+          <a:p>
+            <a:pPr indent="0" marL="0">
+              <a:buNone/>
+            </a:pPr>
+            <a:r>
+              <a:rPr lang="en-US" sz="2000" b="1" dirty="0">
                 <a:solidFill>
                   <a:srgbClr val="58BE8A"/>
                 </a:solidFill>
@@ -5499,9 +5499,9 @@
                 <a:ea typeface="Calibri" pitchFamily="34" charset="-122"/>
                 <a:cs typeface="Calibri" pitchFamily="34" charset="-120"/>
               </a:rPr>
-              <a:t>—</a:t>
-            </a:r>
-            <a:endParaRPr lang="en-US" sz="1300" dirty="0"/>
+              <a:t>·</a:t>
+            </a:r>
+            <a:endParaRPr lang="en-US" sz="2000" dirty="0"/>
           </a:p>
         </p:txBody>
       </p:sp>
@@ -5558,7 +5558,7 @@
                 <a:ea typeface="Calibri" pitchFamily="34" charset="-122"/>
                 <a:cs typeface="Calibri" pitchFamily="34" charset="-120"/>
               </a:rPr>
-              <a:t> — the first published figures for CIP-112 batch settlement, going to the Canton forum whatever happens here.</a:t>
+              <a:t>: the first published figures for CIP-112 batch settlement, going to the Canton forum whatever happens here.</a:t>
             </a:r>
             <a:endParaRPr lang="en-US" sz="1300" dirty="0"/>
           </a:p>
@@ -6650,24 +6650,24 @@
         </p:nvSpPr>
         <p:spPr>
           <a:xfrm>
-            <a:off x="800100" y="3840480"/>
-            <a:ext cx="274320" cy="274320"/>
-          </a:xfrm>
-          <a:prstGeom prst="rect">
-            <a:avLst/>
-          </a:prstGeom>
-          <a:noFill/>
-          <a:ln/>
-        </p:spPr>
-        <p:txBody>
-          <a:bodyPr wrap="square" lIns="0" tIns="0" rIns="0" bIns="0" rtlCol="0" anchor="ctr"/>
-          <a:lstStyle/>
-          <a:p>
-            <a:pPr indent="0" marL="0">
-              <a:buNone/>
-            </a:pPr>
-            <a:r>
-              <a:rPr lang="en-US" sz="1300" dirty="0">
+            <a:off x="836676" y="3813048"/>
+            <a:ext cx="274320" cy="292608"/>
+          </a:xfrm>
+          <a:prstGeom prst="rect">
+            <a:avLst/>
+          </a:prstGeom>
+          <a:noFill/>
+          <a:ln/>
+        </p:spPr>
+        <p:txBody>
+          <a:bodyPr wrap="square" lIns="0" tIns="0" rIns="0" bIns="0" rtlCol="0" anchor="ctr"/>
+          <a:lstStyle/>
+          <a:p>
+            <a:pPr indent="0" marL="0">
+              <a:buNone/>
+            </a:pPr>
+            <a:r>
+              <a:rPr lang="en-US" sz="2000" b="1" dirty="0">
                 <a:solidFill>
                   <a:srgbClr val="58BE8A"/>
                 </a:solidFill>
@@ -6675,9 +6675,9 @@
                 <a:ea typeface="Calibri" pitchFamily="34" charset="-122"/>
                 <a:cs typeface="Calibri" pitchFamily="34" charset="-120"/>
               </a:rPr>
-              <a:t>—</a:t>
-            </a:r>
-            <a:endParaRPr lang="en-US" sz="1300" dirty="0"/>
+              <a:t>·</a:t>
+            </a:r>
+            <a:endParaRPr lang="en-US" sz="2000" dirty="0"/>
           </a:p>
         </p:txBody>
       </p:sp>
@@ -6717,7 +6717,7 @@
                 <a:ea typeface="Calibri" pitchFamily="34" charset="-122"/>
                 <a:cs typeface="Calibri" pitchFamily="34" charset="-120"/>
               </a:rPr>
-              <a:t>The register is confidential by law in most markets.</a:t>
+              <a:t>A bondholder register is not public information, and in many markets is protected by data-protection or banking-secrecy rules.</a:t>
             </a:r>
             <a:endParaRPr lang="en-US" sz="1300" dirty="0"/>
           </a:p>
@@ -6731,24 +6731,24 @@
         </p:nvSpPr>
         <p:spPr>
           <a:xfrm>
-            <a:off x="800100" y="4352544"/>
-            <a:ext cx="274320" cy="274320"/>
-          </a:xfrm>
-          <a:prstGeom prst="rect">
-            <a:avLst/>
-          </a:prstGeom>
-          <a:noFill/>
-          <a:ln/>
-        </p:spPr>
-        <p:txBody>
-          <a:bodyPr wrap="square" lIns="0" tIns="0" rIns="0" bIns="0" rtlCol="0" anchor="ctr"/>
-          <a:lstStyle/>
-          <a:p>
-            <a:pPr indent="0" marL="0">
-              <a:buNone/>
-            </a:pPr>
-            <a:r>
-              <a:rPr lang="en-US" sz="1300" dirty="0">
+            <a:off x="836676" y="4325112"/>
+            <a:ext cx="274320" cy="292608"/>
+          </a:xfrm>
+          <a:prstGeom prst="rect">
+            <a:avLst/>
+          </a:prstGeom>
+          <a:noFill/>
+          <a:ln/>
+        </p:spPr>
+        <p:txBody>
+          <a:bodyPr wrap="square" lIns="0" tIns="0" rIns="0" bIns="0" rtlCol="0" anchor="ctr"/>
+          <a:lstStyle/>
+          <a:p>
+            <a:pPr indent="0" marL="0">
+              <a:buNone/>
+            </a:pPr>
+            <a:r>
+              <a:rPr lang="en-US" sz="2000" b="1" dirty="0">
                 <a:solidFill>
                   <a:srgbClr val="58BE8A"/>
                 </a:solidFill>
@@ -6756,9 +6756,9 @@
                 <a:ea typeface="Calibri" pitchFamily="34" charset="-122"/>
                 <a:cs typeface="Calibri" pitchFamily="34" charset="-120"/>
               </a:rPr>
-              <a:t>—</a:t>
-            </a:r>
-            <a:endParaRPr lang="en-US" sz="1300" dirty="0"/>
+              <a:t>·</a:t>
+            </a:r>
+            <a:endParaRPr lang="en-US" sz="2000" dirty="0"/>
           </a:p>
         </p:txBody>
       </p:sp>
@@ -6798,7 +6798,7 @@
                 <a:ea typeface="Calibri" pitchFamily="34" charset="-122"/>
                 <a:cs typeface="Calibri" pitchFamily="34" charset="-120"/>
               </a:rPr>
-              <a:t>It is commercially sensitive in all of them — it is the client list.</a:t>
+              <a:t>It is commercially sensitive in all of them: it is the client list.</a:t>
             </a:r>
             <a:endParaRPr lang="en-US" sz="1300" dirty="0"/>
           </a:p>
@@ -6812,24 +6812,24 @@
         </p:nvSpPr>
         <p:spPr>
           <a:xfrm>
-            <a:off x="800100" y="4864608"/>
-            <a:ext cx="274320" cy="274320"/>
-          </a:xfrm>
-          <a:prstGeom prst="rect">
-            <a:avLst/>
-          </a:prstGeom>
-          <a:noFill/>
-          <a:ln/>
-        </p:spPr>
-        <p:txBody>
-          <a:bodyPr wrap="square" lIns="0" tIns="0" rIns="0" bIns="0" rtlCol="0" anchor="ctr"/>
-          <a:lstStyle/>
-          <a:p>
-            <a:pPr indent="0" marL="0">
-              <a:buNone/>
-            </a:pPr>
-            <a:r>
-              <a:rPr lang="en-US" sz="1300" dirty="0">
+            <a:off x="836676" y="4837176"/>
+            <a:ext cx="274320" cy="292608"/>
+          </a:xfrm>
+          <a:prstGeom prst="rect">
+            <a:avLst/>
+          </a:prstGeom>
+          <a:noFill/>
+          <a:ln/>
+        </p:spPr>
+        <p:txBody>
+          <a:bodyPr wrap="square" lIns="0" tIns="0" rIns="0" bIns="0" rtlCol="0" anchor="ctr"/>
+          <a:lstStyle/>
+          <a:p>
+            <a:pPr indent="0" marL="0">
+              <a:buNone/>
+            </a:pPr>
+            <a:r>
+              <a:rPr lang="en-US" sz="2000" b="1" dirty="0">
                 <a:solidFill>
                   <a:srgbClr val="58BE8A"/>
                 </a:solidFill>
@@ -6837,9 +6837,9 @@
                 <a:ea typeface="Calibri" pitchFamily="34" charset="-122"/>
                 <a:cs typeface="Calibri" pitchFamily="34" charset="-120"/>
               </a:rPr>
-              <a:t>—</a:t>
-            </a:r>
-            <a:endParaRPr lang="en-US" sz="1300" dirty="0"/>
+              <a:t>·</a:t>
+            </a:r>
+            <a:endParaRPr lang="en-US" sz="2000" dirty="0"/>
           </a:p>
         </p:txBody>
       </p:sp>
@@ -7396,7 +7396,7 @@
                 <a:ea typeface="Calibri" pitchFamily="34" charset="-122"/>
                 <a:cs typeface="Calibri" pitchFamily="34" charset="-120"/>
               </a:rPr>
-              <a:t>Not after three days of chasing returns and rejects. The transaction commits, and that is the answer.</a:t>
+              <a:t>Not after working the 29% of income events that do not go straight through, on Canton’s own published figures. The transaction commits, and that is the answer.</a:t>
             </a:r>
             <a:endParaRPr lang="en-US" sz="1100" dirty="0"/>
           </a:p>
@@ -7916,7 +7916,7 @@
                 <a:ea typeface="Calibri" pitchFamily="34" charset="-122"/>
                 <a:cs typeface="Calibri" pitchFamily="34" charset="-120"/>
               </a:rPr>
-              <a:t> — each holder signs one standing agreement with the paying agent.</a:t>
+              <a:t>: each holder signs one standing agreement with the paying agent.</a:t>
             </a:r>
             <a:endParaRPr lang="en-US" sz="1300" dirty="0"/>
           </a:p>
@@ -8014,7 +8014,7 @@
                 <a:ea typeface="Calibri" pitchFamily="34" charset="-122"/>
                 <a:cs typeface="Calibri" pitchFamily="34" charset="-120"/>
               </a:rPr>
-              <a:t> — the register is snapshotted and entitlements calculated, rounded so the parts sum to the announced total exactly.</a:t>
+              <a:t>: the register is snapshotted and entitlements calculated, rounded so the parts sum to the announced total exactly.</a:t>
             </a:r>
             <a:endParaRPr lang="en-US" sz="1300" dirty="0"/>
           </a:p>
@@ -8112,7 +8112,7 @@
                 <a:ea typeface="Calibri" pitchFamily="34" charset="-122"/>
                 <a:cs typeface="Calibri" pitchFamily="34" charset="-120"/>
               </a:rPr>
-              <a:t> — the agent sets aside the cash and prepares one allocation per holder.</a:t>
+              <a:t>: the agent sets aside the cash and prepares one allocation per holder.</a:t>
             </a:r>
             <a:endParaRPr lang="en-US" sz="1300" dirty="0"/>
           </a:p>
@@ -8210,7 +8210,7 @@
                 <a:ea typeface="Calibri" pitchFamily="34" charset="-122"/>
                 <a:cs typeface="Calibri" pitchFamily="34" charset="-120"/>
               </a:rPr>
-              <a:t> — one settlement. Every leg, or none.</a:t>
+              <a:t>: one settlement. Every leg, or none.</a:t>
             </a:r>
             <a:endParaRPr lang="en-US" sz="1300" dirty="0"/>
           </a:p>
@@ -8802,7 +8802,7 @@
                 <a:ea typeface="Calibri" pitchFamily="34" charset="-122"/>
                 <a:cs typeface="Calibri" pitchFamily="34" charset="-120"/>
               </a:rPr>
-              <a:t>Five holders paid in a single transaction — 8,421.88 USD. The deliberate failure was run first and refused: one holder not ready, nobody paid.</a:t>
+              <a:t>Five holders paid in a single transaction, 8,421.88 USD. The deliberate failure was run first and refused: one holder not ready, nobody paid.</a:t>
             </a:r>
             <a:endParaRPr lang="en-US" sz="1500" dirty="0"/>
           </a:p>
@@ -9148,24 +9148,24 @@
         </p:nvSpPr>
         <p:spPr>
           <a:xfrm>
-            <a:off x="800100" y="3429000"/>
-            <a:ext cx="274320" cy="274320"/>
-          </a:xfrm>
-          <a:prstGeom prst="rect">
-            <a:avLst/>
-          </a:prstGeom>
-          <a:noFill/>
-          <a:ln/>
-        </p:spPr>
-        <p:txBody>
-          <a:bodyPr wrap="square" lIns="0" tIns="0" rIns="0" bIns="0" rtlCol="0" anchor="ctr"/>
-          <a:lstStyle/>
-          <a:p>
-            <a:pPr indent="0" marL="0">
-              <a:buNone/>
-            </a:pPr>
-            <a:r>
-              <a:rPr lang="en-US" sz="1300" dirty="0">
+            <a:off x="836676" y="3401568"/>
+            <a:ext cx="274320" cy="292608"/>
+          </a:xfrm>
+          <a:prstGeom prst="rect">
+            <a:avLst/>
+          </a:prstGeom>
+          <a:noFill/>
+          <a:ln/>
+        </p:spPr>
+        <p:txBody>
+          <a:bodyPr wrap="square" lIns="0" tIns="0" rIns="0" bIns="0" rtlCol="0" anchor="ctr"/>
+          <a:lstStyle/>
+          <a:p>
+            <a:pPr indent="0" marL="0">
+              <a:buNone/>
+            </a:pPr>
+            <a:r>
+              <a:rPr lang="en-US" sz="2000" b="1" dirty="0">
                 <a:solidFill>
                   <a:srgbClr val="175E43"/>
                 </a:solidFill>
@@ -9173,9 +9173,9 @@
                 <a:ea typeface="Calibri" pitchFamily="34" charset="-122"/>
                 <a:cs typeface="Calibri" pitchFamily="34" charset="-120"/>
               </a:rPr>
-              <a:t>—</a:t>
-            </a:r>
-            <a:endParaRPr lang="en-US" sz="1300" dirty="0"/>
+              <a:t>·</a:t>
+            </a:r>
+            <a:endParaRPr lang="en-US" sz="2000" dirty="0"/>
           </a:p>
         </p:txBody>
       </p:sp>
@@ -9229,24 +9229,24 @@
         </p:nvSpPr>
         <p:spPr>
           <a:xfrm>
-            <a:off x="800100" y="3941064"/>
-            <a:ext cx="274320" cy="274320"/>
-          </a:xfrm>
-          <a:prstGeom prst="rect">
-            <a:avLst/>
-          </a:prstGeom>
-          <a:noFill/>
-          <a:ln/>
-        </p:spPr>
-        <p:txBody>
-          <a:bodyPr wrap="square" lIns="0" tIns="0" rIns="0" bIns="0" rtlCol="0" anchor="ctr"/>
-          <a:lstStyle/>
-          <a:p>
-            <a:pPr indent="0" marL="0">
-              <a:buNone/>
-            </a:pPr>
-            <a:r>
-              <a:rPr lang="en-US" sz="1300" dirty="0">
+            <a:off x="836676" y="3913632"/>
+            <a:ext cx="274320" cy="292608"/>
+          </a:xfrm>
+          <a:prstGeom prst="rect">
+            <a:avLst/>
+          </a:prstGeom>
+          <a:noFill/>
+          <a:ln/>
+        </p:spPr>
+        <p:txBody>
+          <a:bodyPr wrap="square" lIns="0" tIns="0" rIns="0" bIns="0" rtlCol="0" anchor="ctr"/>
+          <a:lstStyle/>
+          <a:p>
+            <a:pPr indent="0" marL="0">
+              <a:buNone/>
+            </a:pPr>
+            <a:r>
+              <a:rPr lang="en-US" sz="2000" b="1" dirty="0">
                 <a:solidFill>
                   <a:srgbClr val="175E43"/>
                 </a:solidFill>
@@ -9254,9 +9254,9 @@
                 <a:ea typeface="Calibri" pitchFamily="34" charset="-122"/>
                 <a:cs typeface="Calibri" pitchFamily="34" charset="-120"/>
               </a:rPr>
-              <a:t>—</a:t>
-            </a:r>
-            <a:endParaRPr lang="en-US" sz="1300" dirty="0"/>
+              <a:t>·</a:t>
+            </a:r>
+            <a:endParaRPr lang="en-US" sz="2000" dirty="0"/>
           </a:p>
         </p:txBody>
       </p:sp>
@@ -9296,7 +9296,7 @@
                 <a:ea typeface="Calibri" pitchFamily="34" charset="-122"/>
                 <a:cs typeface="Calibri" pitchFamily="34" charset="-120"/>
               </a:rPr>
-              <a:t>One holder deliberately left out. Press the button — refused, and the ledger names them.</a:t>
+              <a:t>One holder deliberately left out. Press the button: refused, and the ledger names them.</a:t>
             </a:r>
             <a:endParaRPr lang="en-US" sz="1300" dirty="0"/>
           </a:p>
@@ -9310,24 +9310,24 @@
         </p:nvSpPr>
         <p:spPr>
           <a:xfrm>
-            <a:off x="800100" y="4453128"/>
-            <a:ext cx="274320" cy="274320"/>
-          </a:xfrm>
-          <a:prstGeom prst="rect">
-            <a:avLst/>
-          </a:prstGeom>
-          <a:noFill/>
-          <a:ln/>
-        </p:spPr>
-        <p:txBody>
-          <a:bodyPr wrap="square" lIns="0" tIns="0" rIns="0" bIns="0" rtlCol="0" anchor="ctr"/>
-          <a:lstStyle/>
-          <a:p>
-            <a:pPr indent="0" marL="0">
-              <a:buNone/>
-            </a:pPr>
-            <a:r>
-              <a:rPr lang="en-US" sz="1300" dirty="0">
+            <a:off x="836676" y="4425696"/>
+            <a:ext cx="274320" cy="292608"/>
+          </a:xfrm>
+          <a:prstGeom prst="rect">
+            <a:avLst/>
+          </a:prstGeom>
+          <a:noFill/>
+          <a:ln/>
+        </p:spPr>
+        <p:txBody>
+          <a:bodyPr wrap="square" lIns="0" tIns="0" rIns="0" bIns="0" rtlCol="0" anchor="ctr"/>
+          <a:lstStyle/>
+          <a:p>
+            <a:pPr indent="0" marL="0">
+              <a:buNone/>
+            </a:pPr>
+            <a:r>
+              <a:rPr lang="en-US" sz="2000" b="1" dirty="0">
                 <a:solidFill>
                   <a:srgbClr val="175E43"/>
                 </a:solidFill>
@@ -9335,9 +9335,9 @@
                 <a:ea typeface="Calibri" pitchFamily="34" charset="-122"/>
                 <a:cs typeface="Calibri" pitchFamily="34" charset="-120"/>
               </a:rPr>
-              <a:t>—</a:t>
-            </a:r>
-            <a:endParaRPr lang="en-US" sz="1300" dirty="0"/>
+              <a:t>·</a:t>
+            </a:r>
+            <a:endParaRPr lang="en-US" sz="2000" dirty="0"/>
           </a:p>
         </p:txBody>
       </p:sp>
@@ -9391,24 +9391,24 @@
         </p:nvSpPr>
         <p:spPr>
           <a:xfrm>
-            <a:off x="800100" y="4965192"/>
-            <a:ext cx="274320" cy="274320"/>
-          </a:xfrm>
-          <a:prstGeom prst="rect">
-            <a:avLst/>
-          </a:prstGeom>
-          <a:noFill/>
-          <a:ln/>
-        </p:spPr>
-        <p:txBody>
-          <a:bodyPr wrap="square" lIns="0" tIns="0" rIns="0" bIns="0" rtlCol="0" anchor="ctr"/>
-          <a:lstStyle/>
-          <a:p>
-            <a:pPr indent="0" marL="0">
-              <a:buNone/>
-            </a:pPr>
-            <a:r>
-              <a:rPr lang="en-US" sz="1300" dirty="0">
+            <a:off x="836676" y="4937760"/>
+            <a:ext cx="274320" cy="292608"/>
+          </a:xfrm>
+          <a:prstGeom prst="rect">
+            <a:avLst/>
+          </a:prstGeom>
+          <a:noFill/>
+          <a:ln/>
+        </p:spPr>
+        <p:txBody>
+          <a:bodyPr wrap="square" lIns="0" tIns="0" rIns="0" bIns="0" rtlCol="0" anchor="ctr"/>
+          <a:lstStyle/>
+          <a:p>
+            <a:pPr indent="0" marL="0">
+              <a:buNone/>
+            </a:pPr>
+            <a:r>
+              <a:rPr lang="en-US" sz="2000" b="1" dirty="0">
                 <a:solidFill>
                   <a:srgbClr val="175E43"/>
                 </a:solidFill>
@@ -9416,9 +9416,9 @@
                 <a:ea typeface="Calibri" pitchFamily="34" charset="-122"/>
                 <a:cs typeface="Calibri" pitchFamily="34" charset="-120"/>
               </a:rPr>
-              <a:t>—</a:t>
-            </a:r>
-            <a:endParaRPr lang="en-US" sz="1300" dirty="0"/>
+              <a:t>·</a:t>
+            </a:r>
+            <a:endParaRPr lang="en-US" sz="2000" dirty="0"/>
           </a:p>
         </p:txBody>
       </p:sp>

</xml_diff>

<commit_message>
add operator sign-in, checked in the proxy
</commit_message>
<xml_diff>
--- a/docs/Indivisa-pitch.pptx
+++ b/docs/Indivisa-pitch.pptx
@@ -4613,7 +4613,7 @@
         </p:nvSpPr>
         <p:spPr>
           <a:xfrm>
-            <a:off x="836676" y="3493008"/>
+            <a:off x="836676" y="3374136"/>
             <a:ext cx="274320" cy="292608"/>
           </a:xfrm>
           <a:prstGeom prst="rect">
@@ -4652,7 +4652,7 @@
         </p:nvSpPr>
         <p:spPr>
           <a:xfrm>
-            <a:off x="1147572" y="3520440"/>
+            <a:off x="1147572" y="3401568"/>
             <a:ext cx="9326880" cy="685800"/>
           </a:xfrm>
           <a:prstGeom prst="rect">
@@ -4680,7 +4680,7 @@
                 <a:ea typeface="Calibri" pitchFamily="34" charset="-122"/>
                 <a:cs typeface="Calibri" pitchFamily="34" charset="-120"/>
               </a:rPr>
-              <a:t>Production onboarding</a:t>
+              <a:t>The set-up surface</a:t>
             </a:r>
             <a:pPr indent="0" marL="0">
               <a:lnSpc>
@@ -4697,7 +4697,7 @@
                 <a:ea typeface="Calibri" pitchFamily="34" charset="-122"/>
                 <a:cs typeface="Calibri" pitchFamily="34" charset="-120"/>
               </a:rPr>
-              <a:t>: holders sign through a real client, not a script.</a:t>
+              <a:t>: the console settles a run; it does not keep the register. Holders, positions and the schedule come from systems a paying agent already runs, and in the demo a script stands in for them. That boundary is deliberate — it is why Indivisa works against registers that already exist.</a:t>
             </a:r>
             <a:endParaRPr lang="en-US" sz="1200" dirty="0"/>
           </a:p>
@@ -4711,7 +4711,7 @@
         </p:nvSpPr>
         <p:spPr>
           <a:xfrm>
-            <a:off x="836676" y="4005072"/>
+            <a:off x="836676" y="4105656"/>
             <a:ext cx="274320" cy="292608"/>
           </a:xfrm>
           <a:prstGeom prst="rect">
@@ -4750,7 +4750,7 @@
         </p:nvSpPr>
         <p:spPr>
           <a:xfrm>
-            <a:off x="1147572" y="4032504"/>
+            <a:off x="1147572" y="4133088"/>
             <a:ext cx="9326880" cy="685800"/>
           </a:xfrm>
           <a:prstGeom prst="rect">
@@ -4778,7 +4778,7 @@
                 <a:ea typeface="Calibri" pitchFamily="34" charset="-122"/>
                 <a:cs typeface="Calibri" pitchFamily="34" charset="-120"/>
               </a:rPr>
-              <a:t>The scheduled agent</a:t>
+              <a:t>Production onboarding</a:t>
             </a:r>
             <a:pPr indent="0" marL="0">
               <a:lnSpc>
@@ -4795,7 +4795,7 @@
                 <a:ea typeface="Calibri" pitchFamily="34" charset="-122"/>
                 <a:cs typeface="Calibri" pitchFamily="34" charset="-120"/>
               </a:rPr>
-              <a:t>: today a person presses the button; in production a daemon watches payment dates.</a:t>
+              <a:t>: holders sign through a real client, not a script.</a:t>
             </a:r>
             <a:endParaRPr lang="en-US" sz="1200" dirty="0"/>
           </a:p>
@@ -4809,7 +4809,7 @@
         </p:nvSpPr>
         <p:spPr>
           <a:xfrm>
-            <a:off x="836676" y="4517136"/>
+            <a:off x="836676" y="4617720"/>
             <a:ext cx="274320" cy="292608"/>
           </a:xfrm>
           <a:prstGeom prst="rect">
@@ -4848,7 +4848,7 @@
         </p:nvSpPr>
         <p:spPr>
           <a:xfrm>
-            <a:off x="1147572" y="4544568"/>
+            <a:off x="1147572" y="4645152"/>
             <a:ext cx="9326880" cy="685800"/>
           </a:xfrm>
           <a:prstGeom prst="rect">
@@ -4876,7 +4876,7 @@
                 <a:ea typeface="Calibri" pitchFamily="34" charset="-122"/>
                 <a:cs typeface="Calibri" pitchFamily="34" charset="-120"/>
               </a:rPr>
-              <a:t>Real cash</a:t>
+              <a:t>The scheduled agent</a:t>
             </a:r>
             <a:pPr indent="0" marL="0">
               <a:lnSpc>
@@ -4893,7 +4893,7 @@
                 <a:ea typeface="Calibri" pitchFamily="34" charset="-122"/>
                 <a:cs typeface="Calibri" pitchFamily="34" charset="-120"/>
               </a:rPr>
-              <a:t>: a production run settles Canton Coin or a registry's own token. The model never names the asset, so this is a field and one registry adapter, not a rewrite.</a:t>
+              <a:t>: today a person presses the button; in production a daemon watches payment dates.</a:t>
             </a:r>
             <a:endParaRPr lang="en-US" sz="1200" dirty="0"/>
           </a:p>
@@ -4907,7 +4907,7 @@
         </p:nvSpPr>
         <p:spPr>
           <a:xfrm>
-            <a:off x="836676" y="5230368"/>
+            <a:off x="836676" y="5129784"/>
             <a:ext cx="274320" cy="292608"/>
           </a:xfrm>
           <a:prstGeom prst="rect">
@@ -4946,7 +4946,105 @@
         </p:nvSpPr>
         <p:spPr>
           <a:xfrm>
-            <a:off x="1147572" y="5257800"/>
+            <a:off x="1147572" y="5157216"/>
+            <a:ext cx="9326880" cy="685800"/>
+          </a:xfrm>
+          <a:prstGeom prst="rect">
+            <a:avLst/>
+          </a:prstGeom>
+          <a:noFill/>
+          <a:ln/>
+        </p:spPr>
+        <p:txBody>
+          <a:bodyPr wrap="square" lIns="0" tIns="0" rIns="0" bIns="0" rtlCol="0" anchor="t"/>
+          <a:lstStyle/>
+          <a:p>
+            <a:pPr indent="0" marL="0">
+              <a:lnSpc>
+                <a:spcPts val="1656"/>
+              </a:lnSpc>
+              <a:buNone/>
+            </a:pPr>
+            <a:r>
+              <a:rPr lang="en-US" sz="1200" b="1" dirty="0">
+                <a:solidFill>
+                  <a:srgbClr val="E9EFEA"/>
+                </a:solidFill>
+                <a:latin typeface="Calibri" pitchFamily="34" charset="0"/>
+                <a:ea typeface="Calibri" pitchFamily="34" charset="-122"/>
+                <a:cs typeface="Calibri" pitchFamily="34" charset="-120"/>
+              </a:rPr>
+              <a:t>Real cash</a:t>
+            </a:r>
+            <a:pPr indent="0" marL="0">
+              <a:lnSpc>
+                <a:spcPts val="1656"/>
+              </a:lnSpc>
+              <a:buNone/>
+            </a:pPr>
+            <a:r>
+              <a:rPr lang="en-US" sz="1200" dirty="0">
+                <a:solidFill>
+                  <a:srgbClr val="8FA398"/>
+                </a:solidFill>
+                <a:latin typeface="Calibri" pitchFamily="34" charset="0"/>
+                <a:ea typeface="Calibri" pitchFamily="34" charset="-122"/>
+                <a:cs typeface="Calibri" pitchFamily="34" charset="-120"/>
+              </a:rPr>
+              <a:t>: a production run settles Canton Coin or a registry's own token. The model never names the asset, so this is a field and one registry adapter, not a rewrite.</a:t>
+            </a:r>
+            <a:endParaRPr lang="en-US" sz="1200" dirty="0"/>
+          </a:p>
+        </p:txBody>
+      </p:sp>
+      <p:sp>
+        <p:nvSpPr>
+          <p:cNvPr id="16" name="Text 14"/>
+          <p:cNvSpPr txBox="1"/>
+          <p:nvPr/>
+        </p:nvSpPr>
+        <p:spPr>
+          <a:xfrm>
+            <a:off x="836676" y="5843016"/>
+            <a:ext cx="274320" cy="292608"/>
+          </a:xfrm>
+          <a:prstGeom prst="rect">
+            <a:avLst/>
+          </a:prstGeom>
+          <a:noFill/>
+          <a:ln/>
+        </p:spPr>
+        <p:txBody>
+          <a:bodyPr wrap="square" lIns="0" tIns="0" rIns="0" bIns="0" rtlCol="0" anchor="ctr"/>
+          <a:lstStyle/>
+          <a:p>
+            <a:pPr indent="0" marL="0">
+              <a:buNone/>
+            </a:pPr>
+            <a:r>
+              <a:rPr lang="en-US" sz="1900" b="1" dirty="0">
+                <a:solidFill>
+                  <a:srgbClr val="58BE8A"/>
+                </a:solidFill>
+                <a:latin typeface="Calibri" pitchFamily="34" charset="0"/>
+                <a:ea typeface="Calibri" pitchFamily="34" charset="-122"/>
+                <a:cs typeface="Calibri" pitchFamily="34" charset="-120"/>
+              </a:rPr>
+              <a:t>·</a:t>
+            </a:r>
+            <a:endParaRPr lang="en-US" sz="1900" dirty="0"/>
+          </a:p>
+        </p:txBody>
+      </p:sp>
+      <p:sp>
+        <p:nvSpPr>
+          <p:cNvPr id="17" name="Text 15"/>
+          <p:cNvSpPr txBox="1"/>
+          <p:nvPr/>
+        </p:nvSpPr>
+        <p:spPr>
+          <a:xfrm>
+            <a:off x="1147572" y="5870448"/>
             <a:ext cx="9326880" cy="685800"/>
           </a:xfrm>
           <a:prstGeom prst="rect">

</xml_diff>

<commit_message>
document withdrawal as a lifecycle control
</commit_message>
<xml_diff>
--- a/docs/Indivisa-pitch.pptx
+++ b/docs/Indivisa-pitch.pptx
@@ -4653,7 +4653,7 @@
         <p:spPr>
           <a:xfrm>
             <a:off x="1147572" y="3401568"/>
-            <a:ext cx="9326880" cy="685800"/>
+            <a:ext cx="10241280" cy="685800"/>
           </a:xfrm>
           <a:prstGeom prst="rect">
             <a:avLst/>
@@ -4680,7 +4680,7 @@
                 <a:ea typeface="Calibri" pitchFamily="34" charset="-122"/>
                 <a:cs typeface="Calibri" pitchFamily="34" charset="-120"/>
               </a:rPr>
-              <a:t>The set-up surface</a:t>
+              <a:t>Access control</a:t>
             </a:r>
             <a:pPr indent="0" marL="0">
               <a:lnSpc>
@@ -4697,7 +4697,7 @@
                 <a:ea typeface="Calibri" pitchFamily="34" charset="-122"/>
                 <a:cs typeface="Calibri" pitchFamily="34" charset="-120"/>
               </a:rPr>
-              <a:t>: the console settles a run; it does not keep the register. Holders, positions and the schedule come from systems a paying agent already runs, and in the demo a script stands in for them. That boundary is deliberate — it is why Indivisa works against registers that already exist.</a:t>
+              <a:t>: an operator signs in before the console reads or writes anything, and the check sits in the proxy that holds the credentials, not in the page. There are no roles yet — no maker-checker, where one person prepares a run and another releases it. For a payout that is the control an auditor asks about first.</a:t>
             </a:r>
             <a:endParaRPr lang="en-US" sz="1200" dirty="0"/>
           </a:p>
@@ -4705,13 +4705,13 @@
       </p:sp>
       <p:sp>
         <p:nvSpPr>
-          <p:cNvPr id="10" name="Text 8"/>
-          <p:cNvSpPr txBox="1"/>
-          <p:nvPr/>
-        </p:nvSpPr>
-        <p:spPr>
-          <a:xfrm>
-            <a:off x="836676" y="4105656"/>
+          <p:cNvPr id="8" name="Text 6"/>
+          <p:cNvSpPr txBox="1"/>
+          <p:nvPr/>
+        </p:nvSpPr>
+        <p:spPr>
+          <a:xfrm>
+            <a:off x="836676" y="3959352"/>
             <a:ext cx="274320" cy="292608"/>
           </a:xfrm>
           <a:prstGeom prst="rect">
@@ -4744,14 +4744,14 @@
       </p:sp>
       <p:sp>
         <p:nvSpPr>
-          <p:cNvPr id="11" name="Text 9"/>
-          <p:cNvSpPr txBox="1"/>
-          <p:nvPr/>
-        </p:nvSpPr>
-        <p:spPr>
-          <a:xfrm>
-            <a:off x="1147572" y="4133088"/>
-            <a:ext cx="9326880" cy="685800"/>
+          <p:cNvPr id="9" name="Text 7"/>
+          <p:cNvSpPr txBox="1"/>
+          <p:nvPr/>
+        </p:nvSpPr>
+        <p:spPr>
+          <a:xfrm>
+            <a:off x="1147572" y="3986784"/>
+            <a:ext cx="10241280" cy="685800"/>
           </a:xfrm>
           <a:prstGeom prst="rect">
             <a:avLst/>
@@ -4778,7 +4778,7 @@
                 <a:ea typeface="Calibri" pitchFamily="34" charset="-122"/>
                 <a:cs typeface="Calibri" pitchFamily="34" charset="-120"/>
               </a:rPr>
-              <a:t>Production onboarding</a:t>
+              <a:t>The set-up surface</a:t>
             </a:r>
             <a:pPr indent="0" marL="0">
               <a:lnSpc>
@@ -4795,7 +4795,7 @@
                 <a:ea typeface="Calibri" pitchFamily="34" charset="-122"/>
                 <a:cs typeface="Calibri" pitchFamily="34" charset="-120"/>
               </a:rPr>
-              <a:t>: holders sign through a real client, not a script.</a:t>
+              <a:t>: the console settles a run; it does not keep the register. Holders, positions and the schedule come from systems a paying agent already runs, and in the demo a script stands in for them. That boundary is deliberate — it is why Indivisa works against registers that already exist.</a:t>
             </a:r>
             <a:endParaRPr lang="en-US" sz="1200" dirty="0"/>
           </a:p>
@@ -4803,13 +4803,13 @@
       </p:sp>
       <p:sp>
         <p:nvSpPr>
-          <p:cNvPr id="12" name="Text 10"/>
-          <p:cNvSpPr txBox="1"/>
-          <p:nvPr/>
-        </p:nvSpPr>
-        <p:spPr>
-          <a:xfrm>
-            <a:off x="836676" y="4617720"/>
+          <p:cNvPr id="8" name="Text 6"/>
+          <p:cNvSpPr txBox="1"/>
+          <p:nvPr/>
+        </p:nvSpPr>
+        <p:spPr>
+          <a:xfrm>
+            <a:off x="836676" y="4544568"/>
             <a:ext cx="274320" cy="292608"/>
           </a:xfrm>
           <a:prstGeom prst="rect">
@@ -4842,14 +4842,14 @@
       </p:sp>
       <p:sp>
         <p:nvSpPr>
-          <p:cNvPr id="13" name="Text 11"/>
-          <p:cNvSpPr txBox="1"/>
-          <p:nvPr/>
-        </p:nvSpPr>
-        <p:spPr>
-          <a:xfrm>
-            <a:off x="1147572" y="4645152"/>
-            <a:ext cx="9326880" cy="685800"/>
+          <p:cNvPr id="9" name="Text 7"/>
+          <p:cNvSpPr txBox="1"/>
+          <p:nvPr/>
+        </p:nvSpPr>
+        <p:spPr>
+          <a:xfrm>
+            <a:off x="1147572" y="4572000"/>
+            <a:ext cx="10241280" cy="685800"/>
           </a:xfrm>
           <a:prstGeom prst="rect">
             <a:avLst/>
@@ -4876,7 +4876,7 @@
                 <a:ea typeface="Calibri" pitchFamily="34" charset="-122"/>
                 <a:cs typeface="Calibri" pitchFamily="34" charset="-120"/>
               </a:rPr>
-              <a:t>The scheduled agent</a:t>
+              <a:t>Production onboarding</a:t>
             </a:r>
             <a:pPr indent="0" marL="0">
               <a:lnSpc>
@@ -4893,7 +4893,7 @@
                 <a:ea typeface="Calibri" pitchFamily="34" charset="-122"/>
                 <a:cs typeface="Calibri" pitchFamily="34" charset="-120"/>
               </a:rPr>
-              <a:t>: today a person presses the button; in production a daemon watches payment dates.</a:t>
+              <a:t>: holders sign through a real client, not a script.</a:t>
             </a:r>
             <a:endParaRPr lang="en-US" sz="1200" dirty="0"/>
           </a:p>
@@ -4901,13 +4901,13 @@
       </p:sp>
       <p:sp>
         <p:nvSpPr>
-          <p:cNvPr id="14" name="Text 12"/>
-          <p:cNvSpPr txBox="1"/>
-          <p:nvPr/>
-        </p:nvSpPr>
-        <p:spPr>
-          <a:xfrm>
-            <a:off x="836676" y="5129784"/>
+          <p:cNvPr id="8" name="Text 6"/>
+          <p:cNvSpPr txBox="1"/>
+          <p:nvPr/>
+        </p:nvSpPr>
+        <p:spPr>
+          <a:xfrm>
+            <a:off x="836676" y="4919472"/>
             <a:ext cx="274320" cy="292608"/>
           </a:xfrm>
           <a:prstGeom prst="rect">
@@ -4940,14 +4940,14 @@
       </p:sp>
       <p:sp>
         <p:nvSpPr>
-          <p:cNvPr id="15" name="Text 13"/>
-          <p:cNvSpPr txBox="1"/>
-          <p:nvPr/>
-        </p:nvSpPr>
-        <p:spPr>
-          <a:xfrm>
-            <a:off x="1147572" y="5157216"/>
-            <a:ext cx="9326880" cy="685800"/>
+          <p:cNvPr id="9" name="Text 7"/>
+          <p:cNvSpPr txBox="1"/>
+          <p:nvPr/>
+        </p:nvSpPr>
+        <p:spPr>
+          <a:xfrm>
+            <a:off x="1147572" y="4946904"/>
+            <a:ext cx="10241280" cy="685800"/>
           </a:xfrm>
           <a:prstGeom prst="rect">
             <a:avLst/>
@@ -4974,7 +4974,7 @@
                 <a:ea typeface="Calibri" pitchFamily="34" charset="-122"/>
                 <a:cs typeface="Calibri" pitchFamily="34" charset="-120"/>
               </a:rPr>
-              <a:t>Real cash</a:t>
+              <a:t>The scheduled agent</a:t>
             </a:r>
             <a:pPr indent="0" marL="0">
               <a:lnSpc>
@@ -4991,7 +4991,7 @@
                 <a:ea typeface="Calibri" pitchFamily="34" charset="-122"/>
                 <a:cs typeface="Calibri" pitchFamily="34" charset="-120"/>
               </a:rPr>
-              <a:t>: a production run settles Canton Coin or a registry's own token. The model never names the asset, so this is a field and one registry adapter, not a rewrite.</a:t>
+              <a:t>: today a person presses the button; in production a daemon watches payment dates.</a:t>
             </a:r>
             <a:endParaRPr lang="en-US" sz="1200" dirty="0"/>
           </a:p>
@@ -4999,13 +4999,13 @@
       </p:sp>
       <p:sp>
         <p:nvSpPr>
-          <p:cNvPr id="16" name="Text 14"/>
-          <p:cNvSpPr txBox="1"/>
-          <p:nvPr/>
-        </p:nvSpPr>
-        <p:spPr>
-          <a:xfrm>
-            <a:off x="836676" y="5843016"/>
+          <p:cNvPr id="8" name="Text 6"/>
+          <p:cNvSpPr txBox="1"/>
+          <p:nvPr/>
+        </p:nvSpPr>
+        <p:spPr>
+          <a:xfrm>
+            <a:off x="836676" y="5294376"/>
             <a:ext cx="274320" cy="292608"/>
           </a:xfrm>
           <a:prstGeom prst="rect">
@@ -5038,14 +5038,112 @@
       </p:sp>
       <p:sp>
         <p:nvSpPr>
-          <p:cNvPr id="17" name="Text 15"/>
-          <p:cNvSpPr txBox="1"/>
-          <p:nvPr/>
-        </p:nvSpPr>
-        <p:spPr>
-          <a:xfrm>
-            <a:off x="1147572" y="5870448"/>
-            <a:ext cx="9326880" cy="685800"/>
+          <p:cNvPr id="9" name="Text 7"/>
+          <p:cNvSpPr txBox="1"/>
+          <p:nvPr/>
+        </p:nvSpPr>
+        <p:spPr>
+          <a:xfrm>
+            <a:off x="1147572" y="5321808"/>
+            <a:ext cx="10241280" cy="685800"/>
+          </a:xfrm>
+          <a:prstGeom prst="rect">
+            <a:avLst/>
+          </a:prstGeom>
+          <a:noFill/>
+          <a:ln/>
+        </p:spPr>
+        <p:txBody>
+          <a:bodyPr wrap="square" lIns="0" tIns="0" rIns="0" bIns="0" rtlCol="0" anchor="t"/>
+          <a:lstStyle/>
+          <a:p>
+            <a:pPr indent="0" marL="0">
+              <a:lnSpc>
+                <a:spcPts val="1656"/>
+              </a:lnSpc>
+              <a:buNone/>
+            </a:pPr>
+            <a:r>
+              <a:rPr lang="en-US" sz="1200" b="1" dirty="0">
+                <a:solidFill>
+                  <a:srgbClr val="E9EFEA"/>
+                </a:solidFill>
+                <a:latin typeface="Calibri" pitchFamily="34" charset="0"/>
+                <a:ea typeface="Calibri" pitchFamily="34" charset="-122"/>
+                <a:cs typeface="Calibri" pitchFamily="34" charset="-120"/>
+              </a:rPr>
+              <a:t>Real cash</a:t>
+            </a:r>
+            <a:pPr indent="0" marL="0">
+              <a:lnSpc>
+                <a:spcPts val="1656"/>
+              </a:lnSpc>
+              <a:buNone/>
+            </a:pPr>
+            <a:r>
+              <a:rPr lang="en-US" sz="1200" dirty="0">
+                <a:solidFill>
+                  <a:srgbClr val="8FA398"/>
+                </a:solidFill>
+                <a:latin typeface="Calibri" pitchFamily="34" charset="0"/>
+                <a:ea typeface="Calibri" pitchFamily="34" charset="-122"/>
+                <a:cs typeface="Calibri" pitchFamily="34" charset="-120"/>
+              </a:rPr>
+              <a:t>: a production run settles Canton Coin or a registry's own token. The model never names the asset, so this is a field and one registry adapter, not a rewrite.</a:t>
+            </a:r>
+            <a:endParaRPr lang="en-US" sz="1200" dirty="0"/>
+          </a:p>
+        </p:txBody>
+      </p:sp>
+      <p:sp>
+        <p:nvSpPr>
+          <p:cNvPr id="8" name="Text 6"/>
+          <p:cNvSpPr txBox="1"/>
+          <p:nvPr/>
+        </p:nvSpPr>
+        <p:spPr>
+          <a:xfrm>
+            <a:off x="836676" y="5669280"/>
+            <a:ext cx="274320" cy="292608"/>
+          </a:xfrm>
+          <a:prstGeom prst="rect">
+            <a:avLst/>
+          </a:prstGeom>
+          <a:noFill/>
+          <a:ln/>
+        </p:spPr>
+        <p:txBody>
+          <a:bodyPr wrap="square" lIns="0" tIns="0" rIns="0" bIns="0" rtlCol="0" anchor="ctr"/>
+          <a:lstStyle/>
+          <a:p>
+            <a:pPr indent="0" marL="0">
+              <a:buNone/>
+            </a:pPr>
+            <a:r>
+              <a:rPr lang="en-US" sz="1900" b="1" dirty="0">
+                <a:solidFill>
+                  <a:srgbClr val="58BE8A"/>
+                </a:solidFill>
+                <a:latin typeface="Calibri" pitchFamily="34" charset="0"/>
+                <a:ea typeface="Calibri" pitchFamily="34" charset="-122"/>
+                <a:cs typeface="Calibri" pitchFamily="34" charset="-120"/>
+              </a:rPr>
+              <a:t>·</a:t>
+            </a:r>
+            <a:endParaRPr lang="en-US" sz="1900" dirty="0"/>
+          </a:p>
+        </p:txBody>
+      </p:sp>
+      <p:sp>
+        <p:nvSpPr>
+          <p:cNvPr id="9" name="Text 7"/>
+          <p:cNvSpPr txBox="1"/>
+          <p:nvPr/>
+        </p:nvSpPr>
+        <p:spPr>
+          <a:xfrm>
+            <a:off x="1147572" y="5696712"/>
+            <a:ext cx="10241280" cy="685800"/>
           </a:xfrm>
           <a:prstGeom prst="rect">
             <a:avLst/>

</xml_diff>

<commit_message>
Re-export the deck with the corrected benchmark wording and quickstart
</commit_message>
<xml_diff>
--- a/docs/Indivisa-pitch.pptx
+++ b/docs/Indivisa-pitch.pptx
@@ -2268,6 +2268,10 @@
             <a:prstDash val="solid"/>
           </a:ln>
         </p:spPr>
+        <p:txBody>
+          <a:bodyPr/>
+          <a:p/>
+        </p:txBody>
       </p:sp>
       <p:sp>
         <p:nvSpPr>
@@ -2479,6 +2483,10 @@
             <a:prstDash val="solid"/>
           </a:ln>
         </p:spPr>
+        <p:txBody>
+          <a:bodyPr/>
+          <a:p/>
+        </p:txBody>
       </p:sp>
       <p:sp>
         <p:nvSpPr>
@@ -3391,6 +3399,10 @@
             <a:prstDash val="solid"/>
           </a:ln>
         </p:spPr>
+        <p:txBody>
+          <a:bodyPr/>
+          <a:p/>
+        </p:txBody>
       </p:sp>
       <p:sp>
         <p:nvSpPr>
@@ -3495,6 +3507,10 @@
           </a:solidFill>
           <a:ln/>
         </p:spPr>
+        <p:txBody>
+          <a:bodyPr/>
+          <a:p/>
+        </p:txBody>
       </p:sp>
       <p:sp>
         <p:nvSpPr>
@@ -3632,6 +3648,10 @@
           </a:solidFill>
           <a:ln/>
         </p:spPr>
+        <p:txBody>
+          <a:bodyPr/>
+          <a:p/>
+        </p:txBody>
       </p:sp>
       <p:sp>
         <p:nvSpPr>
@@ -3783,7 +3803,7 @@
                 <a:ea typeface="Consolas" pitchFamily="34" charset="-122"/>
                 <a:cs typeface="Consolas" pitchFamily="34" charset="-120"/>
               </a:rPr>
-              <a:t>The threshold is enforced by the ledger, not by our code. In the local demo all three nodes are ours; on DevNet the second is BitSafe's. Four-eyes needs a way back out: a request can be withdrawn until it executes, and both the asking and the withdrawal stay in the ledger history. After settlement there is nothing to withdraw — the correction is a new payment, not an edit.</a:t>
+              <a:t>The threshold is enforced by the ledger, not by our code. In the local demo all three nodes are ours; on DevNet the second is BitSafe's. Four-eyes needs a way back out: a request can be withdrawn until it executes, and both the asking and the withdrawal stay in the ledger history. After settlement there is nothing to withdraw: the correction is a new payment, not an edit.</a:t>
             </a:r>
             <a:endParaRPr lang="en-US" sz="800" dirty="0"/>
           </a:p>
@@ -3921,6 +3941,10 @@
             <a:prstDash val="solid"/>
           </a:ln>
         </p:spPr>
+        <p:txBody>
+          <a:bodyPr/>
+          <a:p/>
+        </p:txBody>
       </p:sp>
       <p:sp>
         <p:nvSpPr>
@@ -4025,6 +4049,10 @@
             <a:prstDash val="solid"/>
           </a:ln>
         </p:spPr>
+        <p:txBody>
+          <a:bodyPr/>
+          <a:p/>
+        </p:txBody>
       </p:sp>
       <p:sp>
         <p:nvSpPr>
@@ -4129,6 +4157,10 @@
             <a:prstDash val="solid"/>
           </a:ln>
         </p:spPr>
+        <p:txBody>
+          <a:bodyPr/>
+          <a:p/>
+        </p:txBody>
       </p:sp>
       <p:sp>
         <p:nvSpPr>
@@ -4233,6 +4265,10 @@
             <a:prstDash val="solid"/>
           </a:ln>
         </p:spPr>
+        <p:txBody>
+          <a:bodyPr/>
+          <a:p/>
+        </p:txBody>
       </p:sp>
       <p:sp>
         <p:nvSpPr>
@@ -4447,6 +4483,10 @@
             <a:prstDash val="solid"/>
           </a:ln>
         </p:spPr>
+        <p:txBody>
+          <a:bodyPr/>
+          <a:p/>
+        </p:txBody>
       </p:sp>
       <p:sp>
         <p:nvSpPr>
@@ -4697,7 +4737,7 @@
                 <a:ea typeface="Calibri" pitchFamily="34" charset="-122"/>
                 <a:cs typeface="Calibri" pitchFamily="34" charset="-120"/>
               </a:rPr>
-              <a:t>: an operator signs in before the console reads or writes anything, and the check sits in the proxy that holds the credentials, not in the page. There are no roles yet — no maker-checker, where one person prepares a run and another releases it. For a payout that is the control an auditor asks about first.</a:t>
+              <a:t>: an operator signs in before the console reads or writes anything, and the check sits in the proxy that holds the credentials, not in the page. There are no roles yet: no maker-checker, where one person prepares a run and another releases it. For a payout that is the control an auditor asks about first.</a:t>
             </a:r>
             <a:endParaRPr lang="en-US" sz="1200" dirty="0"/>
           </a:p>
@@ -4795,7 +4835,7 @@
                 <a:ea typeface="Calibri" pitchFamily="34" charset="-122"/>
                 <a:cs typeface="Calibri" pitchFamily="34" charset="-120"/>
               </a:rPr>
-              <a:t>: the console settles a run; it does not keep the register. Holders, positions and the schedule come from systems a paying agent already runs, and in the demo a script stands in for them. That boundary is deliberate — it is why Indivisa works against registers that already exist.</a:t>
+              <a:t>: the console settles a run; it does not keep the register. Holders, positions and the schedule come from systems a paying agent already runs, and in the demo a script stands in for them. That boundary is deliberate, and it is why Indivisa works against registers that already exist.</a:t>
             </a:r>
             <a:endParaRPr lang="en-US" sz="1200" dirty="0"/>
           </a:p>
@@ -5325,6 +5365,10 @@
             <a:prstDash val="solid"/>
           </a:ln>
         </p:spPr>
+        <p:txBody>
+          <a:bodyPr/>
+          <a:p/>
+        </p:txBody>
       </p:sp>
       <p:sp>
         <p:nvSpPr>
@@ -5939,6 +5983,10 @@
             <a:prstDash val="solid"/>
           </a:ln>
         </p:spPr>
+        <p:txBody>
+          <a:bodyPr/>
+          <a:p/>
+        </p:txBody>
       </p:sp>
       <p:sp>
         <p:nvSpPr>
@@ -5996,7 +6044,7 @@
                 <a:ea typeface="Consolas" pitchFamily="34" charset="-122"/>
                 <a:cs typeface="Consolas" pitchFamily="34" charset="-120"/>
               </a:rPr>
-              <a:t>Run it yourself:   cd judge &amp;&amp; docker compose up</a:t>
+              <a:t>Run it yourself:   cd quickstart &amp;&amp; docker compose up</a:t>
             </a:r>
             <a:endParaRPr lang="en-US" sz="1050" dirty="0"/>
           </a:p>
@@ -6173,6 +6221,10 @@
             <a:prstDash val="solid"/>
           </a:ln>
         </p:spPr>
+        <p:txBody>
+          <a:bodyPr/>
+          <a:p/>
+        </p:txBody>
       </p:sp>
       <p:sp>
         <p:nvSpPr>
@@ -6753,6 +6805,10 @@
             <a:prstDash val="solid"/>
           </a:ln>
         </p:spPr>
+        <p:txBody>
+          <a:bodyPr/>
+          <a:p/>
+        </p:txBody>
       </p:sp>
       <p:sp>
         <p:nvSpPr>
@@ -7213,6 +7269,10 @@
             <a:prstDash val="solid"/>
           </a:ln>
         </p:spPr>
+        <p:txBody>
+          <a:bodyPr/>
+          <a:p/>
+        </p:txBody>
       </p:sp>
       <p:sp>
         <p:nvSpPr>
@@ -7412,6 +7472,10 @@
             <a:prstDash val="solid"/>
           </a:ln>
         </p:spPr>
+        <p:txBody>
+          <a:bodyPr/>
+          <a:p/>
+        </p:txBody>
       </p:sp>
       <p:sp>
         <p:nvSpPr>
@@ -7513,6 +7577,10 @@
           </a:solidFill>
           <a:ln/>
         </p:spPr>
+        <p:txBody>
+          <a:bodyPr/>
+          <a:p/>
+        </p:txBody>
       </p:sp>
       <p:sp>
         <p:nvSpPr>
@@ -7617,6 +7685,10 @@
           </a:solidFill>
           <a:ln/>
         </p:spPr>
+        <p:txBody>
+          <a:bodyPr/>
+          <a:p/>
+        </p:txBody>
       </p:sp>
       <p:sp>
         <p:nvSpPr>
@@ -7721,6 +7793,10 @@
           </a:solidFill>
           <a:ln/>
         </p:spPr>
+        <p:txBody>
+          <a:bodyPr/>
+          <a:p/>
+        </p:txBody>
       </p:sp>
       <p:sp>
         <p:nvSpPr>
@@ -7977,6 +8053,10 @@
             <a:prstDash val="solid"/>
           </a:ln>
         </p:spPr>
+        <p:txBody>
+          <a:bodyPr/>
+          <a:p/>
+        </p:txBody>
       </p:sp>
       <p:sp>
         <p:nvSpPr>
@@ -8583,6 +8663,10 @@
             <a:prstDash val="solid"/>
           </a:ln>
         </p:spPr>
+        <p:txBody>
+          <a:bodyPr/>
+          <a:p/>
+        </p:txBody>
       </p:sp>
       <p:sp>
         <p:nvSpPr>
@@ -8880,6 +8964,10 @@
             <a:prstDash val="solid"/>
           </a:ln>
         </p:spPr>
+        <p:txBody>
+          <a:bodyPr/>
+          <a:p/>
+        </p:txBody>
       </p:sp>
       <p:sp>
         <p:nvSpPr>
@@ -9023,6 +9111,10 @@
           </a:solidFill>
           <a:ln/>
         </p:spPr>
+        <p:txBody>
+          <a:bodyPr/>
+          <a:p/>
+        </p:txBody>
       </p:sp>
       <p:sp>
         <p:nvSpPr>
@@ -9234,6 +9326,10 @@
             <a:prstDash val="solid"/>
           </a:ln>
         </p:spPr>
+        <p:txBody>
+          <a:bodyPr/>
+          <a:p/>
+        </p:txBody>
       </p:sp>
       <p:sp>
         <p:nvSpPr>
@@ -9296,6 +9392,10 @@
           </a:solidFill>
           <a:ln/>
         </p:spPr>
+        <p:txBody>
+          <a:bodyPr/>
+          <a:p/>
+        </p:txBody>
       </p:sp>
       <p:sp>
         <p:nvSpPr>
@@ -9330,7 +9430,7 @@
                 <a:ea typeface="Consolas" pitchFamily="34" charset="-122"/>
                 <a:cs typeface="Consolas" pitchFamily="34" charset="-120"/>
               </a:rPr>
-              <a:t>cd judge &amp;&amp; docker compose up</a:t>
+              <a:t>cd quickstart &amp;&amp; docker compose up</a:t>
             </a:r>
             <a:endParaRPr lang="en-US" sz="1900" dirty="0"/>
           </a:p>

</xml_diff>